<commit_message>
feat: complete Digital Twin PoC integration, verified ML pipelines, ASCVD risk calculator, evaluated alerts, and refined UI
</commit_message>
<xml_diff>
--- a/docs/presentation.pptx
+++ b/docs/presentation.pptx
@@ -3608,7 +3608,7 @@
                   <a:srgbClr val="282828"/>
                 </a:solidFill>
               </a:rPr>
-              <a:t>Ingests 6-hour sliding windows (72 steps) to predict the next 2-hour trajectory (24 steps), forecasting spikes before onset.</a:t>
+              <a:t>Ingests 6-hour sliding windows (72 steps) of patient CGM data to forecast 2-hour trajectories (24 steps), predicting glycemic excursions and meal-induced spikes before onset.</a:t>
             </a:r>
           </a:p>
           <a:p/>
@@ -3621,7 +3621,7 @@
               </a:defRPr>
             </a:pPr>
             <a:r>
-              <a:t>• 2. XGBoost with SHAP (ASCVD 10-Year Risk): </a:t>
+              <a:t>• 2. ACC/AHA ASCVD Risk Model with Wearable Autonomic Telemetry: </a:t>
             </a:r>
             <a:r>
               <a:rPr b="0">
@@ -3629,7 +3629,7 @@
                   <a:srgbClr val="282828"/>
                 </a:solidFill>
               </a:rPr>
-              <a:t>Combines static clinical history with wearable biometric metrics (resting HR, nocturnal HRV, sleep efficiency) to predict cardiovascular risk with explainable attribution.</a:t>
+              <a:t>Evaluates 10-year cardiovascular event probability using patient longitudinal clinical factors (age, BP, cholesterol ratio, smoking, diabetes) fused with real-time wearable autonomic markers (nocturnal HRV RMSSD, resting HR).</a:t>
             </a:r>
           </a:p>
           <a:p/>
@@ -3642,7 +3642,7 @@
               </a:defRPr>
             </a:pPr>
             <a:r>
-              <a:t>• 3. Multi-Modal Intermediate Fusion Neural Network: </a:t>
+              <a:t>• 3. Counterfactual 'What-If' Simulation Engine: </a:t>
             </a:r>
             <a:r>
               <a:rPr b="0">
@@ -3650,7 +3650,7 @@
                   <a:srgbClr val="282828"/>
                 </a:solidFill>
               </a:rPr>
-              <a:t>A hybrid dual-branch architecture (temporal LSTM branch + static MLP branch) learning joint cross-modal risk representations.</a:t>
+              <a:t>Calculates personalized baseline-vs-scenario risk shifts from exercise, weight loss, and pharmacological titration (Statins, SGLT2i, ACEi) backed by clinical trial relative risk reductions.</a:t>
             </a:r>
           </a:p>
           <a:p/>
@@ -3663,7 +3663,7 @@
               </a:defRPr>
             </a:pPr>
             <a:r>
-              <a:t>• 4. Clinical Alert Manager: </a:t>
+              <a:t>• 4. Clinical Alert Manager with Debouncing: </a:t>
             </a:r>
             <a:r>
               <a:rPr b="0">
@@ -3671,7 +3671,7 @@
                   <a:srgbClr val="282828"/>
                 </a:solidFill>
               </a:rPr>
-              <a:t>Intelligent hysteresis debouncing across 4 triage tiers (Critical, High, Moderate, Info) to prevent alarm fatigue.</a:t>
+              <a:t>Evaluates calculated live vitals and forecast extrema rather than static alerts, enforcing hysteresis cooldown windows (30 min) to prevent alarm fatigue.</a:t>
             </a:r>
           </a:p>
           <a:p/>

</xml_diff>